<commit_message>
Rewrite market script in a more spoken style
</commit_message>
<xml_diff>
--- a/reports/midterm/Can AI Beat the Crowd (Group 2).pptx
+++ b/reports/midterm/Can AI Beat the Crowd (Group 2).pptx
@@ -492,7 +492,7 @@
           <a:lstStyle/>
           <a:p>
             <a:r>
-              <a:t>AARON (1:00). The market as a whole is hard to beat, and that gives us a clean definition for the final. Three takeaways: prices are well calibrated in all four categories; the favorite-longshot bias is small and unstable; and no model we built beats the price. Two limits: some markets close early because the event happened, so 24 hours before close means slightly different things for Yes and No markets; and we have one test period. For the final: an informed trader is not someone who wins a lot, since buying at 95 cents wins a lot too. It is someone whose bets keep beating the price they paid. Jiahong will now show which wallets pay low prices, in other words who buys the long shots.</a:t>
+              <a:t>AARON (1:00). So, three takeaways. One, prices are well calibrated across all four categories. Two, the favorite-longshot bias is small and unstable. Three, no model we built beats the price. Two honest limits. Some markets close early, like "Will X happen by December?" resolving the day it happens, so "a day before close" means slightly different things for different markets. And we only have one test period. But here's why this matters for our final. If the market is this good, winning a lot doesn't mean much. If you only buy things priced at 95 cents, you'll win about 95 percent of the time, and that's not skill. A truly informed trader is someone who keeps beating the price they paid. So the next question is: who's paying the low prices, who's buying the long shots? Jiahong, take it away.</a:t>
             </a:r>
           </a:p>
         </p:txBody>
@@ -1122,7 +1122,7 @@
           <a:lstStyle/>
           <a:p>
             <a:r>
-              <a:t>AARON (0:45). Our question is simple: is the market's price a good probability, and can a model do better? A Yes share pays one dollar if the event happens. If you think the chance is p and the share costs c, your expected profit is p minus c. So people buy until the price matches what the crowd believes, which makes the price a forecast we can grade. A classic finding from betting markets is the favorite-longshot bias: long shots are overpriced. We test whether that shows up here.</a:t>
+              <a:t>AARON (0:45). Thanks, Leo. So like Leo said, our big question is: when Polymarket says something has a 30 percent chance, should we actually believe it? Here's the quick intuition. Take a market like "Will the Lakers win tonight?" A Yes share pays one dollar if they win and zero if they lose. Say it's trading at 40 cents. If you think the Lakers really have a 60 percent chance, that's a good deal: on average you pay 40 and get 60 back. That's this formula. Expected profit is p, what you believe, minus c, the price. So people keep buying until the price matches what the crowd thinks, and that's why we can treat the price as a probability and grade it. Leo also mentioned a classic finding from horse racing: long shots tend to be overpriced. So we asked two things. Is the price right? And can a model do better?</a:t>
             </a:r>
           </a:p>
         </p:txBody>
@@ -1192,7 +1192,7 @@
           <a:lstStyle/>
           <a:p>
             <a:r>
-              <a:t>AARON (1:00). We took every Yes/No market in our four categories that resolved from June to October, and read its price at four points before it closed. The course database has no category field, so we used Polymarket's own event tags. That gives 7,479 markets. We first tried the hourly order book, but it only recorded about a fifth of these markets, so we used the last trade before each point, from 4.1 million trades. Where both sources exist they agree closely: correlation 0.92, median gap under one cent.</a:t>
+              <a:t>AARON (1:00). Here's what we worked with. We took every Yes/No market in our four categories, politics, tech, entertainment and economy, that closed between June and October. Think questions like "Will the Fed cut rates in September?" That's 7,479 markets. For each one we went back in time and asked: what was the price a week before it closed? Three days before? One day? Six hours? To get that, we used the last trade before each of those points, out of about 4.1 million trades. Quick note on why trades: we first tried the order book, but it only covered about a fifth of these markets. Where we had both, they basically agreed, a correlation of 0.92 and less than a cent apart. So trades it is.</a:t>
             </a:r>
           </a:p>
         </p:txBody>
@@ -1262,7 +1262,7 @@
           <a:lstStyle/>
           <a:p>
             <a:r>
-              <a:t>AARON (1:00). When the market says 30 percent, it happens about 30 percent of the time. Each dot groups markets by their price a day before close and shows the share that actually resolved Yes. Perfect calibration is the diagonal, and the dots sit on it. The shaded band is a 95 percent interval. We resample whole events to build it, because markets in one event are linked: only one film can win Best Picture. The same picture holds in all four categories.</a:t>
+              <a:t>AARON (1:00). So, is the crowd right? This is the main picture. We group markets by their price a day before close, and check how often they actually happened. If the market is honest, everything sits on this diagonal. And it does: when the market says 30 percent, it happens about 30 percent of the time. On the right, it's the same story in all four categories. One detail on the shaded band. It's our 95 percent interval, and we built it by resampling whole events, not single markets. Why? Think of the Oscars. Best Picture has ten markets, one per film, but only one film can win. Those aren't ten independent coin flips, so we treat the whole event as one unit.</a:t>
             </a:r>
           </a:p>
         </p:txBody>
@@ -1332,7 +1332,7 @@
           <a:lstStyle/>
           <a:p>
             <a:r>
-              <a:t>AARON (1:15). We find a faint trace of the bias, but it is not stable enough to matter. We summarize calibration with one number: regress the outcome on the log-odds of the price. A slope of 1 is perfect; above 1 means prices are too timid, so long shots are overpriced. Six hours before close the slope is 1.08, and its interval just excludes 1. But it comes entirely from prices under 2 cents or over 98 cents: drop those and the slope is 1.00. And month by month it moves between 0.93 and 1.09, with every interval including 1. So it is a weak effect that changes direction.</a:t>
+              <a:t>AARON (1:15). Now, what about that horse-racing bias we introduced earlier? To check it, we squeeze calibration into one number, the slope. One means perfect. Above one means the market is too timid: long shots are a little too expensive and favorites a little too cheap. Six hours before close we get 1.08, so there is a small trace of the bias. But here's the catch. It comes entirely from the extreme contracts, the ones under 2 cents or over 98 cents. Think of bets like a long-shot candidate winning an election. Take those out, and the slope is exactly 1.00. And month by month, like in this chart, it bounces between 0.93 and 1.09, and every interval includes 1. So the bias is small, and it doesn't stay put.</a:t>
             </a:r>
           </a:p>
         </p:txBody>
@@ -1402,7 +1402,7 @@
           <a:lstStyle/>
           <a:p>
             <a:r>
-              <a:t>AARON (0:45; if short on time, say only the first two sentences). Prices get sharper as the event gets closer, and economic questions stay the hardest. The Brier score is the average squared gap between the price and what happened, so lower is better. Across all markets it roughly halves from a week out to six hours out, from 0.074 to 0.038. Politics improves the most. From three days out to the close, Economy is the hardest category to call.</a:t>
+              <a:t>AARON (0:45; if short on time, say only the first two sentences). Next, timing. This is the Brier score, which is basically how far off the price was from what actually happened. Lower is better. And it makes sense: the closer you get to the event, the better the price. A week out it's 0.074, six hours out it's 0.038, roughly half. Think of an election: a week before, there's still a lot that can happen; the night before, most of the information is already out. Politics improves the most, and economy stays the hardest to call.</a:t>
             </a:r>
           </a:p>
         </p:txBody>
@@ -1472,7 +1472,7 @@
           <a:lstStyle/>
           <a:p>
             <a:r>
-              <a:t>AARON (1:15). We tried to beat the crowd with two models, and neither did. We trained on events that finished before September and tested on September and October. No event sits on both sides, and every feature uses only trades before the time point, so nothing leaks. Model one re-calibrates the price by category and horizon. Model two is gradient boosting with the price plus 18 features known at the time: recent price moves, order flow, volume, number of traders, market age, time to the deadline, category. Both come out no better than the raw price, and the re-calibration is slightly worse. Almost all of the model's weight is on the price itself. That fits the previous slides: a bias that changes direction cannot be learned in summer and used in autumn.</a:t>
+              <a:t>AARON (1:15). So the price is pretty good. Can AI beat it? We tried two models. The first one takes the price and tries to correct it a little, by category and by how far we are from the close. The second is gradient boosting, with the price plus 18 other things you'd know at that moment, like how the price moved over the last day, trading volume, how many people are trading, and how long until the deadline. To keep it fair, we trained on everything that finished before September and tested on September and October, so the model never sees the future. And the answer: neither one beats the raw price. The simple correction actually does slightly worse. When we look inside the boosting model, it leans almost entirely on the price itself. That ties back to the bias slide: if the bias keeps changing month to month, you can't learn it in the summer and use it in the fall.</a:t>
             </a:r>
           </a:p>
         </p:txBody>

</xml_diff>

<commit_message>
Explain the two models in plain words
</commit_message>
<xml_diff>
--- a/reports/midterm/Can AI Beat the Crowd (Group 2).pptx
+++ b/reports/midterm/Can AI Beat the Crowd (Group 2).pptx
@@ -1332,7 +1332,7 @@
           <a:lstStyle/>
           <a:p>
             <a:r>
-              <a:t>AARON (1:15). Now, what about that horse-racing bias we introduced earlier? To check it, we squeeze calibration into one number, the slope. One means perfect. Above one means the market is too timid: long shots are a little too expensive and favorites a little too cheap. Six hours before close we get 1.08, so there is a small trace of the bias. But here's the catch. It comes entirely from the extreme contracts, the ones under 2 cents or over 98 cents. Think of bets like a long-shot candidate winning an election. Take those out, and the slope is exactly 1.00. And month by month, like in this chart, it bounces between 0.93 and 1.09, and every interval includes 1. So the bias is small, and it doesn't stay put.</a:t>
+              <a:t>AARON (1:15). Now, what about that horse-racing bias we introduced earlier? To check it, we squeeze calibration into one number, the slope. Technically it's the slope from a logistic regression of what happened on the price, but the idea is simple. One means perfect. Above one means the market is too timid: long shots are a little too expensive and favorites a little too cheap. Six hours before close we get 1.08, so there is a small trace of the bias. But here's the catch. It comes entirely from the extreme contracts, the ones under 2 cents or over 98 cents. Think of bets like a long-shot candidate winning an election. Take those out, and the slope is exactly 1.00. And month by month, like in this chart, it bounces between 0.93 and 1.09, and every interval includes 1. So the bias is small, and it doesn't stay put.</a:t>
             </a:r>
           </a:p>
         </p:txBody>
@@ -1472,7 +1472,7 @@
           <a:lstStyle/>
           <a:p>
             <a:r>
-              <a:t>AARON (1:15). So the price is pretty good. Can AI beat it? We tried two models. The first one takes the price and tries to correct it a little, by category and by how far we are from the close. The second is gradient boosting, with the price plus 18 other things you'd know at that moment, like how the price moved over the last day, trading volume, how many people are trading, and how long until the deadline. To keep it fair, we trained on everything that finished before September and tested on September and October, so the model never sees the future. And the answer: neither one beats the raw price. The simple correction actually does slightly worse. When we look inside the boosting model, it leans almost entirely on the price itself. That ties back to the bias slide: if the bias keeps changing month to month, you can't learn it in the summer and use it in the fall.</a:t>
+              <a:t>AARON (1:30). So the price is pretty good. Can AI beat it? We tried two models. The first is logistic regression, the standard tool for predicting a yes-or-no outcome: it turns inputs into a probability between 0 and 1. We give it the market price, so it learns small corrections, like "when the market says 10 percent, it's really 8," and it can correct differently by category and by how far we are from the close. The second is gradient boosting. It builds a few hundred small decision trees one after another, and each new tree focuses on the mistakes the earlier ones made. Think of a team of analysts where each one fixes what the last one got wrong. That lets it pick up patterns a straight line would miss. We gave it the price plus 18 other things you'd know at that moment, like how the price moved over the last day, trading volume, how many people are trading, and how long until the deadline. To keep it fair, we trained on everything that finished before September and tested on September and October, so the model never sees the future. And the answer: neither one beats the raw price. The simple correction actually does slightly worse. When we look inside the boosting model, it leans almost entirely on the price itself. That ties back to the bias slide: if the bias keeps changing month to month, you can't learn it in the summer and use it in the fall.</a:t>
             </a:r>
           </a:p>
         </p:txBody>

</xml_diff>

<commit_message>
Shorter, more formal market script
</commit_message>
<xml_diff>
--- a/reports/midterm/Can AI Beat the Crowd (Group 2).pptx
+++ b/reports/midterm/Can AI Beat the Crowd (Group 2).pptx
@@ -492,7 +492,7 @@
           <a:lstStyle/>
           <a:p>
             <a:r>
-              <a:t>AARON (1:00). So, three takeaways. One, prices are well calibrated across all four categories. Two, the favorite-longshot bias is small and unstable. Three, no model we built beats the price. Two honest limits. Some markets close early, like "Will X happen by December?" resolving the day it happens, so "a day before close" means slightly different things for different markets. And we only have one test period. But here's why this matters for our final. If the market is this good, winning a lot doesn't mean much. If you only buy things priced at 95 cents, you'll win about 95 percent of the time, and that's not skill. A truly informed trader is someone who keeps beating the price they paid. So the next question is: who's paying the low prices, who's buying the long shots? Jiahong, take it away.</a:t>
+              <a:t>AARON (0:50). To summarize, the market is hard to beat. Prices are well calibrated in all four categories. The favorite-longshot bias is small and unstable. And our models do not beat the price. We have two limitations. Some markets close early when the event happens, and we have only one test period. For the final project, this gives us a clear definition. An informed trader is not someone who wins often, because buying at 95 cents wins about 95 percent of the time. An informed trader consistently beats the price they paid. Next, Jiahong will show which wallets pay low prices.</a:t>
             </a:r>
           </a:p>
         </p:txBody>
@@ -1122,7 +1122,7 @@
           <a:lstStyle/>
           <a:p>
             <a:r>
-              <a:t>AARON (0:45). Thanks, Leo. So like Leo said, our big question is: when Polymarket says something has a 30 percent chance, should we actually believe it? Here's the quick intuition. Take a market like "Will the Lakers win tonight?" A Yes share pays one dollar if they win and zero if they lose. Say it's trading at 40 cents. If you think the Lakers really have a 60 percent chance, that's a good deal: on average you pay 40 and get 60 back. That's this formula. Expected profit is p, what you believe, minus c, the price. So people keep buying until the price matches what the crowd thinks, and that's why we can treat the price as a probability and grade it. Leo also mentioned a classic finding from horse racing: long shots tend to be overpriced. So we asked two things. Is the price right? And can a model do better?</a:t>
+              <a:t>AARON (0:45). Thank you, Leo. As Leo mentioned, our question is whether prediction-market prices are good probabilities. On Polymarket, a Yes share pays one dollar if the event happens. Suppose a share costs 40 cents, but you believe the chance is 60 percent. Then buying it is profitable on average. This is the formula on the slide: expected profit equals p, your belief, minus c, the price. Traders keep buying or selling until the price matches the crowd's belief. So the price can be read as a probability, and we can test it. We ask two questions. First, is the price calibrated? Second, can a model do better?</a:t>
             </a:r>
           </a:p>
         </p:txBody>
@@ -1192,7 +1192,7 @@
           <a:lstStyle/>
           <a:p>
             <a:r>
-              <a:t>AARON (1:00). Here's what we worked with. We took every Yes/No market in our four categories, politics, tech, entertainment and economy, that closed between June and October. Think questions like "Will the Fed cut rates in September?" That's 7,479 markets. For each one we went back in time and asked: what was the price a week before it closed? Three days before? One day? Six hours? To get that, we used the last trade before each of those points, out of about 4.1 million trades. Quick note on why trades: we first tried the order book, but it only covered about a fifth of these markets. Where we had both, they basically agreed, a correlation of 0.92 and less than a cent apart. So trades it is.</a:t>
+              <a:t>AARON (0:50). Here is our data. We used all Yes/No markets in our four categories that closed between June and October 2026. This gives 7,479 markets. For each market, we recorded the price at four points before it closed: seven days, three days, one day, and six hours. The price is the last trade before each point, from 4.1 million trades. We also checked the order book. It covers only 22 percent of these markets, but where both exist, the two prices agree closely, with a correlation of 0.92.</a:t>
             </a:r>
           </a:p>
         </p:txBody>
@@ -1262,7 +1262,7 @@
           <a:lstStyle/>
           <a:p>
             <a:r>
-              <a:t>AARON (1:00). So, is the crowd right? This is the main picture. We group markets by their price a day before close, and check how often they actually happened. If the market is honest, everything sits on this diagonal. And it does: when the market says 30 percent, it happens about 30 percent of the time. On the right, it's the same story in all four categories. One detail on the shaded band. It's our 95 percent interval, and we built it by resampling whole events, not single markets. Why? Think of the Oscars. Best Picture has ten markets, one per film, but only one film can win. Those aren't ten independent coin flips, so we treat the whole event as one unit.</a:t>
+              <a:t>AARON (0:50). This figure shows our main result. We group markets by their price one day before close. Then we check how often each group actually happened. If prices are calibrated, the points lie on the diagonal, and they do. When the market says 30 percent, the event happens about 30 percent of the time. The same holds in all four categories, shown on the right. The shaded band is a 95 percent interval. We resample whole events, not single markets, because markets in one event are linked. For example, only one film can win Best Picture.</a:t>
             </a:r>
           </a:p>
         </p:txBody>
@@ -1332,7 +1332,7 @@
           <a:lstStyle/>
           <a:p>
             <a:r>
-              <a:t>AARON (1:15). Now, what about that horse-racing bias we introduced earlier? To check it, we squeeze calibration into one number, the slope. Technically it's the slope from a logistic regression of what happened on the price, but the idea is simple. One means perfect. Above one means the market is too timid: long shots are a little too expensive and favorites a little too cheap. Six hours before close we get 1.08, so there is a small trace of the bias. But here's the catch. It comes entirely from the extreme contracts, the ones under 2 cents or over 98 cents. Think of bets like a long-shot candidate winning an election. Take those out, and the slope is exactly 1.00. And month by month, like in this chart, it bounces between 0.93 and 1.09, and every interval includes 1. So the bias is small, and it doesn't stay put.</a:t>
+              <a:t>AARON (1:00). Next, we test the favorite-longshot bias that Leo introduced. We summarize calibration with one number: the slope from a logistic regression of the outcome on the price. A slope of one is perfect. A slope above one means long shots are overpriced. Six hours before close, the slope is 1.08, which is a small sign of the bias. However, it comes only from extreme prices, below 2 cents or above 98 cents. Without them, the slope is 1.00. The slope also changes from month to month, between 0.93 and 1.09, and every monthly interval includes one. So the bias is small and not stable.</a:t>
             </a:r>
           </a:p>
         </p:txBody>
@@ -1402,7 +1402,7 @@
           <a:lstStyle/>
           <a:p>
             <a:r>
-              <a:t>AARON (0:45; if short on time, say only the first two sentences). Next, timing. This is the Brier score, which is basically how far off the price was from what actually happened. Lower is better. And it makes sense: the closer you get to the event, the better the price. A week out it's 0.074, six hours out it's 0.038, roughly half. Think of an election: a week before, there's still a lot that can happen; the night before, most of the information is already out. Politics improves the most, and economy stays the hardest to call.</a:t>
+              <a:t>AARON (0:40). This figure shows accuracy over time. We use the Brier score, the average squared error of the price, so lower is better. Accuracy improves as the event gets closer. The score falls from 0.074 one week before close to 0.038 six hours before. Politics improves the most, and Economy remains the hardest category near the close.</a:t>
             </a:r>
           </a:p>
         </p:txBody>
@@ -1472,7 +1472,7 @@
           <a:lstStyle/>
           <a:p>
             <a:r>
-              <a:t>AARON (1:30). So the price is pretty good. Can AI beat it? We tried two models. The first is logistic regression, the standard tool for predicting a yes-or-no outcome: it turns inputs into a probability between 0 and 1. We give it the market price, so it learns small corrections, like "when the market says 10 percent, it's really 8," and it can correct differently by category and by how far we are from the close. The second is gradient boosting. It builds a few hundred small decision trees one after another, and each new tree focuses on the mistakes the earlier ones made. Think of a team of analysts where each one fixes what the last one got wrong. That lets it pick up patterns a straight line would miss. We gave it the price plus 18 other things you'd know at that moment, like how the price moved over the last day, trading volume, how many people are trading, and how long until the deadline. To keep it fair, we trained on everything that finished before September and tested on September and October, so the model never sees the future. And the answer: neither one beats the raw price. The simple correction actually does slightly worse. When we look inside the boosting model, it leans almost entirely on the price itself. That ties back to the bias slide: if the bias keeps changing month to month, you can't learn it in the summer and use it in the fall.</a:t>
+              <a:t>AARON (1:10). Next, we ask whether a model can beat the price. We trained two models. The first is logistic regression, which adjusts the price to correct small biases by category and by time. The second is gradient boosting, which combines many small decision trees, where each tree corrects the errors of the previous ones. It uses the price plus 18 other features, such as recent price changes, trading volume, and time to the deadline. We trained on markets that closed before September and tested on September and October. Neither model beats the market price. Most of the boosting model's weight is on the price itself. This matches the previous result: a bias that changes every month cannot be learned.</a:t>
             </a:r>
           </a:p>
         </p:txBody>

</xml_diff>

<commit_message>
Trim market script to 4 minutes
</commit_message>
<xml_diff>
--- a/reports/midterm/Can AI Beat the Crowd (Group 2).pptx
+++ b/reports/midterm/Can AI Beat the Crowd (Group 2).pptx
@@ -492,7 +492,7 @@
           <a:lstStyle/>
           <a:p>
             <a:r>
-              <a:t>AARON (0:50). To summarize, the market is hard to beat. Prices are well calibrated in all four categories. The favorite-longshot bias is small and unstable. And our models do not beat the price. We have two limitations. Some markets close early when the event happens, and we have only one test period. For the final project, this gives us a clear definition. An informed trader is not someone who wins often, because buying at 95 cents wins about 95 percent of the time. An informed trader consistently beats the price they paid. Next, Jiahong will show which wallets pay low prices.</a:t>
+              <a:t>AARON (0:30). To summarize, the market is hard to beat. Prices are well calibrated, the bias is small and unstable, and our models do not beat the price. So for the final, an informed trader is not someone who wins often, but someone who consistently beats the price they paid. Next, Jiahong will show which wallets pay low prices.</a:t>
             </a:r>
           </a:p>
         </p:txBody>
@@ -1122,7 +1122,7 @@
           <a:lstStyle/>
           <a:p>
             <a:r>
-              <a:t>AARON (0:45). Thank you, Leo. As Leo mentioned, our question is whether prediction-market prices are good probabilities. On Polymarket, a Yes share pays one dollar if the event happens. Suppose a share costs 40 cents, but you believe the chance is 60 percent. Then buying it is profitable on average. This is the formula on the slide: expected profit equals p, your belief, minus c, the price. Traders keep buying or selling until the price matches the crowd's belief. So the price can be read as a probability, and we can test it. We ask two questions. First, is the price calibrated? Second, can a model do better?</a:t>
+              <a:t>AARON (0:30). Thank you, Leo. Our question is whether prediction-market prices are good probabilities. A Yes share pays one dollar if the event happens. If you believe the chance is p and the price is c, your expected profit is p minus c. Traders trade until the price matches the crowd's belief, so the price works as a probability. We test two things: is it calibrated, and can a model do better?</a:t>
             </a:r>
           </a:p>
         </p:txBody>
@@ -1192,7 +1192,7 @@
           <a:lstStyle/>
           <a:p>
             <a:r>
-              <a:t>AARON (0:50). Here is our data. We used all Yes/No markets in our four categories that closed between June and October 2026. This gives 7,479 markets. For each market, we recorded the price at four points before it closed: seven days, three days, one day, and six hours. The price is the last trade before each point, from 4.1 million trades. We also checked the order book. It covers only 22 percent of these markets, but where both exist, the two prices agree closely, with a correlation of 0.92.</a:t>
+              <a:t>AARON (0:30). We used 7,479 resolved Yes/No markets in our four categories, from June to October 2026. For each market, we took the last trade price at four points before close: seven days, three days, one day, and six hours. These prices come from 4.1 million trades.</a:t>
             </a:r>
           </a:p>
         </p:txBody>
@@ -1262,7 +1262,7 @@
           <a:lstStyle/>
           <a:p>
             <a:r>
-              <a:t>AARON (0:50). This figure shows our main result. We group markets by their price one day before close. Then we check how often each group actually happened. If prices are calibrated, the points lie on the diagonal, and they do. When the market says 30 percent, the event happens about 30 percent of the time. The same holds in all four categories, shown on the right. The shaded band is a 95 percent interval. We resample whole events, not single markets, because markets in one event are linked. For example, only one film can win Best Picture.</a:t>
+              <a:t>AARON (0:40). This is our main result. We group markets by their price one day before close and check how often they happened. The points lie on the diagonal: when the market says 30 percent, it happens about 30 percent of the time. This holds in all four categories. The intervals resample whole events, because markets in one event are linked; for example, only one film can win Best Picture.</a:t>
             </a:r>
           </a:p>
         </p:txBody>
@@ -1332,7 +1332,7 @@
           <a:lstStyle/>
           <a:p>
             <a:r>
-              <a:t>AARON (1:00). Next, we test the favorite-longshot bias that Leo introduced. We summarize calibration with one number: the slope from a logistic regression of the outcome on the price. A slope of one is perfect. A slope above one means long shots are overpriced. Six hours before close, the slope is 1.08, which is a small sign of the bias. However, it comes only from extreme prices, below 2 cents or above 98 cents. Without them, the slope is 1.00. The slope also changes from month to month, between 0.93 and 1.09, and every monthly interval includes one. So the bias is small and not stable.</a:t>
+              <a:t>AARON (0:40). Next, the favorite-longshot bias. We measure it with a calibration slope from logistic regression, where one is perfect. Six hours before close, the slope is 1.08, a small sign of the bias. But it comes only from prices below 2 cents or above 98 cents. Without them, the slope is 1.00. It also changes from month to month. So the bias is small and not stable.</a:t>
             </a:r>
           </a:p>
         </p:txBody>
@@ -1402,7 +1402,7 @@
           <a:lstStyle/>
           <a:p>
             <a:r>
-              <a:t>AARON (0:40). This figure shows accuracy over time. We use the Brier score, the average squared error of the price, so lower is better. Accuracy improves as the event gets closer. The score falls from 0.074 one week before close to 0.038 six hours before. Politics improves the most, and Economy remains the hardest category near the close.</a:t>
+              <a:t>AARON (0:20). Accuracy improves as the event gets closer. The Brier score falls from 0.074 one week before close to 0.038 six hours before. Economy stays the hardest category near the close.</a:t>
             </a:r>
           </a:p>
         </p:txBody>
@@ -1472,7 +1472,7 @@
           <a:lstStyle/>
           <a:p>
             <a:r>
-              <a:t>AARON (1:10). Next, we ask whether a model can beat the price. We trained two models. The first is logistic regression, which adjusts the price to correct small biases by category and by time. The second is gradient boosting, which combines many small decision trees, where each tree corrects the errors of the previous ones. It uses the price plus 18 other features, such as recent price changes, trading volume, and time to the deadline. We trained on markets that closed before September and tested on September and October. Neither model beats the market price. Most of the boosting model's weight is on the price itself. This matches the previous result: a bias that changes every month cannot be learned.</a:t>
+              <a:t>AARON (0:45). Can a model beat the price? We tried logistic regression, which corrects the price, and gradient boosting, which combines many decision trees and adds 18 features. We trained on markets before September and tested on September and October. Neither model beats the market price. The boosting model relies almost entirely on the price itself.</a:t>
             </a:r>
           </a:p>
         </p:txBody>

</xml_diff>

<commit_message>
Market script follows the slide text
</commit_message>
<xml_diff>
--- a/reports/midterm/Can AI Beat the Crowd (Group 2).pptx
+++ b/reports/midterm/Can AI Beat the Crowd (Group 2).pptx
@@ -492,7 +492,7 @@
           <a:lstStyle/>
           <a:p>
             <a:r>
-              <a:t>AARON (0:30). To summarize, the market is hard to beat. Prices are well calibrated, the bias is small and unstable, and our models do not beat the price. So for the final, an informed trader is not someone who wins often, but someone who consistently beats the price they paid. Next, Jiahong will show which wallets pay low prices.</a:t>
+              <a:t>AARON (0:40). To summarize our market findings. First, prices broadly match observed outcomes in all four categories. Second, the favorite-longshot bias is small and varies across months. Third, our models do not improve on prices in the September to October test. We have two limits: early resolution changes the meaning of 24 hours before close, and we evaluate one test period. Next, Jiahong will look at the prices traders choose to pay.</a:t>
             </a:r>
           </a:p>
         </p:txBody>
@@ -1122,7 +1122,7 @@
           <a:lstStyle/>
           <a:p>
             <a:r>
-              <a:t>AARON (0:30). Thank you, Leo. Our question is whether prediction-market prices are good probabilities. A Yes share pays one dollar if the event happens. If you believe the chance is p and the price is c, your expected profit is p minus c. Traders trade until the price matches the crowd's belief, so the price works as a probability. We test two things: is it calibrated, and can a model do better?</a:t>
+              <a:t>AARON (0:30). Thank you, Leo. Let's start with prices as probabilities. A Yes share pays one dollar if the event occurs. If p is your belief and c is the price, your expected profit is p minus c, so the price settles at the crowd's belief. This gives us two questions. First, calibration: among events priced at 30 percent, do about 30 percent resolve Yes? Second, model comparison: can a model improve on the price using information available at the time?</a:t>
             </a:r>
           </a:p>
         </p:txBody>
@@ -1192,7 +1192,7 @@
           <a:lstStyle/>
           <a:p>
             <a:r>
-              <a:t>AARON (0:30). We used 7,479 resolved Yes/No markets in our four categories, from June to October 2026. For each market, we took the last trade price at four points before close: seven days, three days, one day, and six hours. These prices come from 4.1 million trades.</a:t>
+              <a:t>AARON (0:35). Here is our data. First, we have 7,479 resolved Yes/No markets in politics, technology, entertainment and economy, closing from June to October 2026. Second, we read prices from 4.1 million trades, using the last trade 7 days, 3 days, 24 hours and 6 hours before close. For evaluation, we use calibration curves and Brier scores. Finally, the order book covers 22 percent of these markets, and where both exist, the correlation is 0.92.</a:t>
             </a:r>
           </a:p>
         </p:txBody>
@@ -1262,7 +1262,7 @@
           <a:lstStyle/>
           <a:p>
             <a:r>
-              <a:t>AARON (0:40). This is our main result. We group markets by their price one day before close and check how often they happened. The points lie on the diagonal: when the market says 30 percent, it happens about 30 percent of the time. This holds in all four categories. The intervals resample whole events, because markets in one event are linked; for example, only one film can win Best Picture.</a:t>
+              <a:t>AARON (0:30). This is market calibration, 24 hours before close, across 5,805 markets. Observed outcomes broadly track market probabilities: events priced near 30 percent resolve Yes about 30 percent of the time. The right panel shows the same pattern in each category. The shaded bands are 95 percent intervals from an event bootstrap.</a:t>
             </a:r>
           </a:p>
         </p:txBody>
@@ -1332,7 +1332,7 @@
           <a:lstStyle/>
           <a:p>
             <a:r>
-              <a:t>AARON (0:40). Next, the favorite-longshot bias. We measure it with a calibration slope from logistic regression, where one is perfect. Six hours before close, the slope is 1.08, a small sign of the bias. But it comes only from prices below 2 cents or above 98 cents. Without them, the slope is 1.00. It also changes from month to month. So the bias is small and not stable.</a:t>
+              <a:t>AARON (0:40). Next, the favorite-longshot bias. We measure it with a calibration slope, where 1 is perfect and above 1 means long shots are overpriced. First, with all prices, the slope 6 hours before close is 1.08, with a 95 percent interval of 1.01 to 1.16. Second, after dropping prices below 2 cents and above 98 cents, it falls to 1.00. And as the chart shows, monthly slopes range from 0.93 to 1.09, and every interval includes 1. So the estimated bias is small.</a:t>
             </a:r>
           </a:p>
         </p:txBody>
@@ -1402,7 +1402,7 @@
           <a:lstStyle/>
           <a:p>
             <a:r>
-              <a:t>AARON (0:20). Accuracy improves as the event gets closer. The Brier score falls from 0.074 one week before close to 0.038 six hours before. Economy stays the hardest category near the close.</a:t>
+              <a:t>AARON (0:20). This slide shows accuracy near market close. Lower Brier scores mean more accurate probabilities. The overall score falls from 0.074 at 7 days to 0.038 at 6 hours. Politics shows the largest improvement, and economy keeps the largest error from 3 days to 6 hours.</a:t>
             </a:r>
           </a:p>
         </p:txBody>
@@ -1472,7 +1472,7 @@
           <a:lstStyle/>
           <a:p>
             <a:r>
-              <a:t>AARON (0:45). Can a model beat the price? We tried logistic regression, which corrects the price, and gradient boosting, which combines many decision trees and adds 18 features. We trained on markets before September and tested on September and October. Neither model beats the market price. The boosting model relies almost entirely on the price itself.</a:t>
+              <a:t>AARON (0:45). Can models improve on market prices? We trained on events before September and tested on 860 events from September and October. We compare three forecasts. First, the market price, with a Brier score of 0.0513. Second, logistic recalibration, which adjusts the price, at 0.0518. Third, gradient boosting, which combines many decision trees with extra features, also at 0.0518. So neither model improves on market prices in this test.</a:t>
             </a:r>
           </a:p>
         </p:txBody>

</xml_diff>